<commit_message>
refactoring: removed at_boundary_ variable from Element (like Face or InterFace which have none) created function in Box which does the determination of this flag on the fly (method is hardly used)
</commit_message>
<xml_diff>
--- a/doc/CSMP_refactoring_debugging.pptx
+++ b/doc/CSMP_refactoring_debugging.pptx
@@ -533,12 +533,8 @@
           </a:p>
           <a:p>
             <a:r>
-              <a:rPr lang="en-US"/>
-              <a:t>- new BOX_BUNDARY </a:t>
-            </a:r>
-            <a:r>
               <a:rPr lang="en-US" dirty="0"/>
-              <a:t>flags? -  INTERNAL_EDGE, EDGE_END, EDGE_INTERSECTION</a:t>
+              <a:t>- new BOX_BUNDARY flags? -  INTERNAL_EDGE, EDGE_END, EDGE_INTERSECTION</a:t>
             </a:r>
           </a:p>
         </p:txBody>
@@ -4012,7 +4008,15 @@
             </a:pPr>
             <a:r>
               <a:rPr lang="en-US" sz="1800" dirty="0"/>
-              <a:t>(Topology)</a:t>
+              <a:t>(</a:t>
+            </a:r>
+            <a:r>
+              <a:rPr lang="en-US" sz="1800" dirty="0" err="1"/>
+              <a:t>ModelTopology</a:t>
+            </a:r>
+            <a:r>
+              <a:rPr lang="en-US" sz="1800" dirty="0"/>
+              <a:t>)</a:t>
             </a:r>
           </a:p>
           <a:p>
@@ -4034,6 +4038,13 @@
             <a:r>
               <a:rPr lang="en-US" sz="1400" dirty="0"/>
               <a:t>split boundaries</a:t>
+            </a:r>
+          </a:p>
+          <a:p>
+            <a:pPr lvl="1"/>
+            <a:r>
+              <a:rPr lang="en-US" sz="1400" dirty="0"/>
+              <a:t>consistency checks</a:t>
             </a:r>
           </a:p>
           <a:p>

</xml_diff>

<commit_message>
chore: refactoring of implicit version of transport scheme chore: cleanup of SplitBoundary creation (fixed bugs with regard to name generation in InsertRegionInto split-boundary) refactoring: Element, Face, InterFace Unassign instead of DetachNeighbor() which would change size of nbor vector at great cost comment: nbor vector should have a constant size, same for node vector, if nothing is connected the pointer will simply be zero
</commit_message>
<xml_diff>
--- a/doc/CSMP_refactoring_debugging.pptx
+++ b/doc/CSMP_refactoring_debugging.pptx
@@ -4091,7 +4091,7 @@
           <p:nvPr>
             <p:extLst>
               <p:ext uri="{D42A27DB-BD31-4B8C-83A1-F6EECF244321}">
-                <p14:modId xmlns:p14="http://schemas.microsoft.com/office/powerpoint/2010/main" val="1628722415"/>
+                <p14:modId xmlns:p14="http://schemas.microsoft.com/office/powerpoint/2010/main" val="1963386208"/>
               </p:ext>
             </p:extLst>
           </p:nvPr>
@@ -5792,8 +5792,27 @@
                     <a:bodyPr/>
                     <a:lstStyle/>
                     <a:p>
-                      <a:pPr algn="ctr"/>
-                      <a:endParaRPr lang="en-US" sz="1800" dirty="0"/>
+                      <a:pPr marL="0" marR="0" lvl="0" indent="0" algn="ctr" defTabSz="914400" rtl="0" eaLnBrk="1" fontAlgn="auto" latinLnBrk="0" hangingPunct="1">
+                        <a:lnSpc>
+                          <a:spcPct val="100000"/>
+                        </a:lnSpc>
+                        <a:spcBef>
+                          <a:spcPts val="0"/>
+                        </a:spcBef>
+                        <a:spcAft>
+                          <a:spcPts val="0"/>
+                        </a:spcAft>
+                        <a:buClrTx/>
+                        <a:buSzTx/>
+                        <a:buFontTx/>
+                        <a:buNone/>
+                        <a:tabLst/>
+                        <a:defRPr/>
+                      </a:pPr>
+                      <a:r>
+                        <a:rPr lang="en-US" sz="1800" dirty="0"/>
+                        <a:t>✓</a:t>
+                      </a:r>
                     </a:p>
                   </a:txBody>
                   <a:tcPr/>

</xml_diff>